<commit_message>
Update Zimmer & Rens proposal to FSM Starter + Fractional CTO L1
Swap the recommended package from Full Service Marketing — Growth +
Master's Circle + Fractional CTO L1 ($15,394/mo) to Full Service
Marketing — Starter + Fractional CTO L1 only ($8,294/mo), per Jacob's
request ahead of today's proposal call. Updated the report HTML,
proposal PPTX/generator, and sales companion PDF/generator; flagged in
section_11_workings.txt that Starter's $20K ad-spend cap is now below
the $23.4K-$37.1K ad spend range still shown in the report.
</commit_message>
<xml_diff>
--- a/zimmer-rens/Zimmer & Rens LLC_August 7, 2026_Proposal.pptx
+++ b/zimmer-rens/Zimmer & Rens LLC_August 7, 2026_Proposal.pptx
@@ -7912,7 +7912,7 @@
                 </a:solidFill>
                 <a:latin typeface="Calibri"/>
               </a:rPr>
-              <a:t>Start Master's Circle coaching for the partners</a:t>
+              <a:t>Free Paul and Taylor from day-to-day admin work</a:t>
             </a:r>
           </a:p>
         </p:txBody>
@@ -8767,7 +8767,7 @@
                 </a:solidFill>
                 <a:latin typeface="Calibri"/>
               </a:rPr>
-              <a:t>FULL SERVICE MARKETING — GROWTH</a:t>
+              <a:t>FULL SERVICE MARKETING — STARTER</a:t>
             </a:r>
           </a:p>
         </p:txBody>
@@ -8800,7 +8800,7 @@
                 </a:solidFill>
                 <a:latin typeface="Calibri"/>
               </a:rPr>
-              <a:t>$7,497</a:t>
+              <a:t>$4,997</a:t>
             </a:r>
           </a:p>
         </p:txBody>
@@ -8866,7 +8866,7 @@
                 </a:solidFill>
                 <a:latin typeface="Calibri"/>
               </a:rPr>
-              <a:t>$8,997/mo</a:t>
+              <a:t>$5,697/mo</a:t>
             </a:r>
           </a:p>
         </p:txBody>
@@ -9067,7 +9067,7 @@
                 </a:solidFill>
                 <a:latin typeface="Calibri"/>
               </a:rPr>
-              <a:t>MASTER'S CIRCLE + FRACTIONAL CTO L1</a:t>
+              <a:t>FRACTIONAL CTO LEVEL 1</a:t>
             </a:r>
           </a:p>
         </p:txBody>
@@ -9100,7 +9100,7 @@
                 </a:solidFill>
                 <a:latin typeface="Calibri"/>
               </a:rPr>
-              <a:t>$7,897</a:t>
+              <a:t>$3,297</a:t>
             </a:r>
           </a:p>
         </p:txBody>
@@ -9166,7 +9166,7 @@
                 </a:solidFill>
                 <a:latin typeface="Calibri"/>
               </a:rPr>
-              <a:t>$8,794/mo</a:t>
+              <a:t>$3,797/mo</a:t>
             </a:r>
           </a:p>
         </p:txBody>
@@ -9244,7 +9244,7 @@
                 </a:solidFill>
                 <a:latin typeface="Calibri"/>
               </a:rPr>
-              <a:t>Peer coaching · AI automation for email &amp; scheduling</a:t>
+              <a:t>AI automation for email &amp; scheduling</a:t>
             </a:r>
           </a:p>
         </p:txBody>
@@ -9355,7 +9355,7 @@
                 </a:solidFill>
                 <a:latin typeface="Calibri"/>
               </a:rPr>
-              <a:t>$15,394 / mo</a:t>
+              <a:t>$8,294 / mo</a:t>
             </a:r>
           </a:p>
         </p:txBody>
@@ -9388,7 +9388,7 @@
                 </a:solidFill>
                 <a:latin typeface="Calibri"/>
               </a:rPr>
-              <a:t>Save $2,397/mo by bundling</a:t>
+              <a:t>Save $1,200/mo by bundling</a:t>
             </a:r>
           </a:p>
         </p:txBody>
@@ -10153,7 +10153,7 @@
                 </a:solidFill>
                 <a:latin typeface="Calibri"/>
               </a:rPr>
-              <a:t>Master's Circle coaching kicks off</a:t>
+              <a:t>Practice area landing pages live for CD &amp; EP</a:t>
             </a:r>
           </a:p>
         </p:txBody>

</xml_diff>